<commit_message>
docs(decks): describe the deployed Cloud Run service + L4 Job architecture
Update the architecture, technology and cost slides of both pitch decks to the
layout that is actually deployed: a CPU-only Cloud Run web service plus a Cloud
Run Job with one NVIDIA L4 per walkthrough, a Cloud Storage bucket mounted on
both, Gemini 3.8 Flash through the Gemini API with the key in Secret Manager, and
no Vertex AI, BigQuery or Pub/Sub. Cost tiles now state ~$0.50 of L4 time per
20-minute walkthrough, ~$0.85 all-in, and a ~$1.20/month idle footprint. The
submission deck's final product link points at the live service. PDFs
regenerated. The architecture diagram images still show the earlier
single-service layout; captions and notes describe the current one.

Co-Authored-By: Claude Fable 5.1 <noreply@anthropic.com>
Claude-Session: https://claude.ai/code/session_01HUmAtjQbXfDaSjpz3oopZg
</commit_message>
<xml_diff>
--- a/docs/pitch-deck/Property_Inspection_AI_Pitch.pptx
+++ b/docs/pitch-deck/Property_Inspection_AI_Pitch.pptx
@@ -3766,7 +3766,7 @@
             </a:pPr>
             <a:r>
               <a:rPr lang="en-US"/>
-              <a:t>Google technology: Gemini on Vertex AI, Gemma 4, Cloud Run with an L4, Cloud Storage, BigQuery, Pub/Sub, Cloud Build and IAM are in the prototype. Next come Document AI for deeds and valuation reports, Vertex AI Search for policy wording, BigQuery ML for risk scoring and AlloyDB.</a:t>
+              <a:t>Google technology: Gemini 3.8 Flash through the Gemini API, Gemma 4, a Cloud Run service plus an L4 Cloud Run Job, Cloud Storage, Secret Manager, Cloud Build, Artifact Registry and IAM are in the prototype. Next come Document AI for deeds and valuation reports, Vertex AI Search for policy wording, BigQuery ML for risk scoring and AlloyDB.</a:t>
             </a:r>
             <a:endParaRPr/>
           </a:p>
@@ -4102,7 +4102,7 @@
             </a:pPr>
             <a:r>
               <a:rPr lang="en-US"/>
-              <a:t>Business model: a pay-per-inspection API, enterprise subscriptions and white-label tools for inspector firms. Unit economics: about 35 cents of Gemini per walkthrough, and about one dollar per Lite video including GPU time at about 1.42 dollars an hour. Pricing per inspection would sit well below a physical visit, to be validated in pilots.</a:t>
+              <a:t>Business model: a pay-per-inspection API, enterprise subscriptions and white-label tools for inspector firms. Unit economics: about 35 cents of Gemini per walkthrough plus about 50 cents of L4 time on a Cloud Run Job, so about 85 cents per walkthrough; idle cost is about $1.20 a month for image storage. Pricing per inspection would sit well below a physical visit, to be validated in pilots.</a:t>
             </a:r>
             <a:endParaRPr/>
           </a:p>
@@ -4942,7 +4942,7 @@
             </a:pPr>
             <a:r>
               <a:rPr lang="en-US"/>
-              <a:t>One inspection record serves five decision-makers: lenders get collateral condition and valuation impact, underwriters get perils and premium loading, claims teams get fraud-checked evidence, inspectors get an AI-drafted report, and owners get a transparent report. Everything lands in BigQuery and Pub/Sub, so each team's system can use it.</a:t>
+              <a:t>One inspection record serves five decision-makers: lenders get collateral condition and valuation impact, underwriters get perils and premium loading, claims teams get fraud-checked evidence, inspectors get an AI-drafted report, and owners get a transparent report. Everything is one JSON record behind a REST API, so each team's system can use it.</a:t>
             </a:r>
             <a:endParaRPr/>
           </a:p>
@@ -5278,7 +5278,7 @@
             </a:pPr>
             <a:r>
               <a:rPr lang="en-US"/>
-              <a:t>Four steps: capture, AI inspection, risk decision, act. A 20-second walkthrough takes about 10.6 minutes end to end on a laptop GPU. In the cloud a Lite video costs about one dollar, of which Gemini is about 35 cents, and nothing while idle because Cloud Run scales to zero.</a:t>
+              <a:t>Four steps: capture, AI inspection, risk decision, act. A 20-second walkthrough takes about 10.6 minutes end to end on a laptop GPU. In the cloud a walkthrough costs about 85 cents: roughly 50 cents of L4 time on a Cloud Run Job plus about 35 cents of Gemini, and nothing while idle because the GPU Job only runs per video and the web service scales to zero.</a:t>
             </a:r>
             <a:endParaRPr/>
           </a:p>
@@ -5446,7 +5446,7 @@
             </a:pPr>
             <a:r>
               <a:rPr lang="en-US"/>
-              <a:t>Architecture: a single Cloud Run service with an L4 GPU runs the API, the web UI, the local models and the 3D engine. Gemini on Vertex AI provides reasoning. Results go to Cloud Storage, BigQuery and Pub/Sub. Deployment is one script, with a least-privilege service account and no keys.</a:t>
+              <a:t>Architecture: one container image, two Cloud Run resources. A CPU-only Cloud Run service serves the web UI and API, accepts uploads, dispatches jobs and shows progress. A Cloud Run Job with one NVIDIA L4 processes each uploaded video: Depth Anything 3 and OpenCV SLAM for the 3D map and coverage, LocateAnything and Gemma 4 for defect detection and verification, Gemini for scene, labels and summary. The GPU is billed only while a video is processing. A Cloud Storage bucket mounted on both holds uploads, job status and results. Gemini 3.8 Flash is called through the Gemini API with the key in Secret Manager: no Vertex AI, BigQuery or Pub/Sub. Deployment is one script through Cloud Build with a least-privilege service account. The diagram still shows the earlier single-service layout; the caption gives the deployed one.</a:t>
             </a:r>
             <a:endParaRPr/>
           </a:p>
@@ -7991,7 +7991,7 @@
         <p:spPr>
           <a:xfrm>
             <a:off x="3566160" y="4069080"/>
-            <a:ext cx="1143000" cy="329184"/>
+            <a:ext cx="1234440" cy="329184"/>
           </a:xfrm>
           <a:prstGeom prst="roundRect">
             <a:avLst>
@@ -8041,7 +8041,7 @@
         <p:spPr>
           <a:xfrm>
             <a:off x="3566160" y="4069080"/>
-            <a:ext cx="1143000" cy="329184"/>
+            <a:ext cx="1234440" cy="329184"/>
           </a:xfrm>
           <a:prstGeom prst="rect">
             <a:avLst/>
@@ -8081,7 +8081,7 @@
                 <a:cs typeface="Google Sans Flex"/>
                 <a:sym typeface="Google Sans Flex"/>
               </a:rPr>
-              <a:t>Vertex AI</a:t>
+              <a:t>Gemini API</a:t>
             </a:r>
             <a:endParaRPr sz="1100" b="0" i="0" u="none" strike="noStrike" cap="none">
               <a:solidFill>
@@ -8217,7 +8217,7 @@
         <p:spPr>
           <a:xfrm>
             <a:off x="2240280" y="4507992"/>
-            <a:ext cx="1143000" cy="329184"/>
+            <a:ext cx="1463040" cy="329184"/>
           </a:xfrm>
           <a:prstGeom prst="roundRect">
             <a:avLst>
@@ -8267,7 +8267,7 @@
         <p:spPr>
           <a:xfrm>
             <a:off x="2240280" y="4507992"/>
-            <a:ext cx="1143000" cy="329184"/>
+            <a:ext cx="1463040" cy="329184"/>
           </a:xfrm>
           <a:prstGeom prst="rect">
             <a:avLst/>
@@ -8307,7 +8307,7 @@
                 <a:cs typeface="Google Sans Flex"/>
                 <a:sym typeface="Google Sans Flex"/>
               </a:rPr>
-              <a:t>BigQuery</a:t>
+              <a:t>Cloud Storage</a:t>
             </a:r>
             <a:endParaRPr sz="1100" b="0" i="0" u="none" strike="noStrike" cap="none">
               <a:solidFill>
@@ -8329,8 +8329,8 @@
         </p:nvSpPr>
         <p:spPr>
           <a:xfrm>
-            <a:off x="3520440" y="4507992"/>
-            <a:ext cx="1005840" cy="329184"/>
+            <a:off x="3840480" y="4507992"/>
+            <a:ext cx="1280160" cy="329184"/>
           </a:xfrm>
           <a:prstGeom prst="roundRect">
             <a:avLst>
@@ -8379,8 +8379,8 @@
         </p:nvSpPr>
         <p:spPr>
           <a:xfrm>
-            <a:off x="3520440" y="4507992"/>
-            <a:ext cx="1005840" cy="329184"/>
+            <a:off x="3840480" y="4507992"/>
+            <a:ext cx="1280160" cy="329184"/>
           </a:xfrm>
           <a:prstGeom prst="rect">
             <a:avLst/>
@@ -8420,7 +8420,7 @@
                 <a:cs typeface="Google Sans Flex"/>
                 <a:sym typeface="Google Sans Flex"/>
               </a:rPr>
-              <a:t>Pub/Sub</a:t>
+              <a:t>Cloud Build</a:t>
             </a:r>
             <a:endParaRPr sz="1100" b="0" i="0" u="none" strike="noStrike" cap="none">
               <a:solidFill>
@@ -18938,7 +18938,7 @@
                   <a:schemeClr val="accent2"/>
                 </a:solidFill>
               </a:rPr>
-              <a:t>GEMINI ON VERTEX AI</a:t>
+              <a:t>GEMINI 3.8 FLASH</a:t>
             </a:r>
             <a:endParaRPr sz="1150"/>
           </a:p>
@@ -26005,7 +26005,7 @@
                 <a:cs typeface="Google Sans Flex"/>
                 <a:sym typeface="Google Sans Flex"/>
               </a:rPr>
-              <a:t>Google Cloud architecture: Cloud Run, Vertex AI, BigQuery, Pub/Sub and deployment</a:t>
+              <a:t>Google Cloud architecture: Cloud Run service + GPU Job, Cloud Storage and deployment</a:t>
             </a:r>
             <a:endParaRPr sz="1100" b="0" i="0" u="none" strike="noStrike" cap="none">
               <a:solidFill>
@@ -27641,7 +27641,7 @@
                 <a:cs typeface="Google Sans Flex"/>
                 <a:sym typeface="Google Sans Flex"/>
               </a:rPr>
-              <a:t>Gemini on Vertex AI, Cloud Run + L4, BigQuery, Pub/Sub, one-command deploy</a:t>
+              <a:t>Gemini API, Cloud Run service + L4 Job, Cloud Storage, one-command deploy</a:t>
             </a:r>
             <a:endParaRPr sz="1100" b="0" i="0" u="none" strike="noStrike" cap="none">
               <a:solidFill>
@@ -28912,7 +28912,7 @@
                 <a:cs typeface="Google Sans Flex"/>
                 <a:sym typeface="Google Sans Flex"/>
               </a:rPr>
-              <a:t>Gemini on Vertex AI</a:t>
+              <a:t>Gemini 3.8 Flash</a:t>
             </a:r>
             <a:endParaRPr sz="1250" b="0" i="0" u="none" strike="noStrike" cap="none">
               <a:solidFill>
@@ -28975,7 +28975,7 @@
                 <a:cs typeface="Google Sans Flex"/>
                 <a:sym typeface="Google Sans Flex"/>
               </a:rPr>
-              <a:t>Scene, authenticity, analysis, grounded Q&amp;A, 3D object names</a:t>
+              <a:t>Via the Gemini API: scene, authenticity, analysis, grounded Q&amp;A, 3D object names</a:t>
             </a:r>
             <a:endParaRPr sz="1000" b="0" i="0" u="none" strike="noStrike" cap="none">
               <a:solidFill>
@@ -29314,7 +29314,7 @@
                 <a:cs typeface="Google Sans Flex"/>
                 <a:sym typeface="Google Sans Flex"/>
               </a:rPr>
-              <a:t>Cloud Run + NVIDIA L4</a:t>
+              <a:t>Cloud Run service + L4 Job</a:t>
             </a:r>
             <a:endParaRPr sz="1250" b="0" i="0" u="none" strike="noStrike" cap="none">
               <a:solidFill>
@@ -29377,7 +29377,7 @@
                 <a:cs typeface="Google Sans Flex"/>
                 <a:sym typeface="Google Sans Flex"/>
               </a:rPr>
-              <a:t>The whole app in one container; scales to zero</a:t>
+              <a:t>One image: CPU web service, L4 GPU Job per video; both scale to zero</a:t>
             </a:r>
             <a:endParaRPr sz="1000" b="0" i="0" u="none" strike="noStrike" cap="none">
               <a:solidFill>
@@ -29578,7 +29578,7 @@
                 <a:cs typeface="Google Sans Flex"/>
                 <a:sym typeface="Google Sans Flex"/>
               </a:rPr>
-              <a:t>FUSE-mounted data: uploads, reports, 3D models</a:t>
+              <a:t>Bucket mounted on both: uploads, job status, reports, 3D models</a:t>
             </a:r>
             <a:endParaRPr sz="1000" b="0" i="0" u="none" strike="noStrike" cap="none">
               <a:solidFill>
@@ -29716,7 +29716,7 @@
                 <a:cs typeface="Google Sans Flex"/>
                 <a:sym typeface="Google Sans Flex"/>
               </a:rPr>
-              <a:t>BigQuery</a:t>
+              <a:t>Secret Manager</a:t>
             </a:r>
             <a:endParaRPr sz="1250" b="0" i="0" u="none" strike="noStrike" cap="none">
               <a:solidFill>
@@ -29779,7 +29779,7 @@
                 <a:cs typeface="Google Sans Flex"/>
                 <a:sym typeface="Google Sans Flex"/>
               </a:rPr>
-              <a:t>One row per inspection: grade, decision, perils, fraud flags, coverage</a:t>
+              <a:t>Gemini API key injected at runtime; no keys in the image or repo</a:t>
             </a:r>
             <a:endParaRPr sz="1000" b="0" i="0" u="none" strike="noStrike" cap="none">
               <a:solidFill>
@@ -29917,7 +29917,7 @@
                 <a:cs typeface="Google Sans Flex"/>
                 <a:sym typeface="Google Sans Flex"/>
               </a:rPr>
-              <a:t>Pub/Sub</a:t>
+              <a:t>Cloud Build</a:t>
             </a:r>
             <a:endParaRPr sz="1250" b="0" i="0" u="none" strike="noStrike" cap="none">
               <a:solidFill>
@@ -29980,7 +29980,7 @@
                 <a:cs typeface="Google Sans Flex"/>
                 <a:sym typeface="Google Sans Flex"/>
               </a:rPr>
-              <a:t>Event-driven hand-off to underwriting and claims</a:t>
+              <a:t>Builds the ~12 GB image; model weights fetched inside the build, never via a laptop</a:t>
             </a:r>
             <a:endParaRPr sz="1000" b="0" i="0" u="none" strike="noStrike" cap="none">
               <a:solidFill>
@@ -30118,7 +30118,7 @@
                 <a:cs typeface="Google Sans Flex"/>
                 <a:sym typeface="Google Sans Flex"/>
               </a:rPr>
-              <a:t>Cloud Build + Artifact Registry</a:t>
+              <a:t>Artifact Registry</a:t>
             </a:r>
             <a:endParaRPr sz="1250" b="0" i="0" u="none" strike="noStrike" cap="none">
               <a:solidFill>
@@ -30181,7 +30181,7 @@
                 <a:cs typeface="Google Sans Flex"/>
                 <a:sym typeface="Google Sans Flex"/>
               </a:rPr>
-              <a:t>Reproducible container build with baked-in models</a:t>
+              <a:t>One image with baked-in weights, shared by the service and the Job</a:t>
             </a:r>
             <a:endParaRPr sz="1000" b="0" i="0" u="none" strike="noStrike" cap="none">
               <a:solidFill>
@@ -30382,7 +30382,7 @@
                 <a:cs typeface="Google Sans Flex"/>
                 <a:sym typeface="Google Sans Flex"/>
               </a:rPr>
-              <a:t>Least privilege, with no keys in production</a:t>
+              <a:t>Least-privilege runtime account for the bucket, the secret and the Job</a:t>
             </a:r>
             <a:endParaRPr sz="1000" b="0" i="0" u="none" strike="noStrike" cap="none">
               <a:solidFill>
@@ -32190,7 +32190,7 @@
                 <a:cs typeface="Google Sans Flex"/>
                 <a:sym typeface="Google Sans Flex"/>
               </a:rPr>
-              <a:t>Raw model outputs are archived, each inspection is a BigQuery record, and the config is versioned.</a:t>
+              <a:t>Raw model outputs are archived, each inspection is a JSON record in Cloud Storage, and the config is versioned.</a:t>
             </a:r>
             <a:endParaRPr sz="1250" b="0" i="0" u="none" strike="noStrike" cap="none">
               <a:solidFill>
@@ -32684,7 +32684,7 @@
                 <a:cs typeface="Google Sans Flex"/>
                 <a:sym typeface="Google Sans Flex"/>
               </a:rPr>
-              <a:t>Service-account access, no API keys in files, an optional UI password, and data stays in the client's own project.</a:t>
+              <a:t>Least-privilege service account, Gemini key in Secret Manager, no keys in files, and data stays in the client's own project.</a:t>
             </a:r>
             <a:endParaRPr sz="1250" b="0" i="0" u="none" strike="noStrike" cap="none">
               <a:solidFill>
@@ -34172,7 +34172,7 @@
                 <a:cs typeface="Google Sans Flex"/>
                 <a:sym typeface="Google Sans Flex"/>
               </a:rPr>
-              <a:t>L4 GPU time</a:t>
+              <a:t>L4 GPU Job</a:t>
             </a:r>
             <a:endParaRPr sz="1250" b="0" i="0" u="none" strike="noStrike" cap="none">
               <a:solidFill>
@@ -34235,7 +34235,7 @@
                 <a:cs typeface="Google Sans Flex"/>
                 <a:sym typeface="Google Sans Flex"/>
               </a:rPr>
-              <a:t>≈ $1.42 per hour (8 vCPU, 32 GiB), scales to zero</a:t>
+              <a:t>≈ $0.50 of L4 time per 20-min walkthrough; no idle GPU</a:t>
             </a:r>
             <a:endParaRPr sz="1150" b="0" i="0" u="none" strike="noStrike" cap="none">
               <a:solidFill>
@@ -34361,7 +34361,7 @@
                 <a:cs typeface="Google Sans Flex"/>
                 <a:sym typeface="Google Sans Flex"/>
               </a:rPr>
-              <a:t>≈ $1 per Lite video, ≈ $1.50 Advanced (GPU + Gemini)</a:t>
+              <a:t>≈ $0.85 per walkthrough, L4 Job + Gemini</a:t>
             </a:r>
             <a:endParaRPr sz="1150" b="0" i="0" u="none" strike="noStrike" cap="none">
               <a:solidFill>
@@ -34424,7 +34424,7 @@
                 <a:cs typeface="Google Sans Flex"/>
                 <a:sym typeface="Google Sans Flex"/>
               </a:rPr>
-              <a:t>Judging period</a:t>
+              <a:t>Idle footprint</a:t>
             </a:r>
             <a:endParaRPr sz="1250" b="0" i="0" u="none" strike="noStrike" cap="none">
               <a:solidFill>
@@ -34487,7 +34487,7 @@
                 <a:cs typeface="Google Sans Flex"/>
                 <a:sym typeface="Google Sans Flex"/>
               </a:rPr>
-              <a:t>≈ $50–70 for two weeks of demo use</a:t>
+              <a:t>≈ $1.20 per month (image storage); $30/month budget alert</a:t>
             </a:r>
             <a:endParaRPr sz="1150" b="0" i="0" u="none" strike="noStrike" cap="none">
               <a:solidFill>
@@ -36184,7 +36184,7 @@
                 <a:cs typeface="Google Sans Flex"/>
                 <a:sym typeface="Google Sans Flex"/>
               </a:rPr>
-              <a:t>Cloud Run, BigQuery, Pub/Sub</a:t>
+              <a:t>Cloud Run service + GPU Job</a:t>
             </a:r>
             <a:endParaRPr sz="1350" b="0" i="0" u="none" strike="noStrike" cap="none">
               <a:solidFill>
@@ -37690,7 +37690,7 @@
                 <a:cs typeface="Google Sans Flex"/>
                 <a:sym typeface="Google Sans Flex"/>
               </a:rPr>
-              <a:t>Prototype v1.0.0  ·  one-command Cloud Run deploy  ·  Gemini · Gemma · BigQuery · Pub/Sub</a:t>
+              <a:t>Prototype v1.0.0  ·  one-command Cloud Run deploy  ·  Gemini · Gemma · Cloud Storage</a:t>
             </a:r>
             <a:endParaRPr sz="1000" b="0" i="0" u="none" strike="noStrike" cap="none">
               <a:solidFill>
@@ -41305,7 +41305,7 @@
                 <a:cs typeface="Google Sans Flex"/>
                 <a:sym typeface="Google Sans Flex"/>
               </a:rPr>
-              <a:t>Same evidence, one record: every inspection is a BigQuery row and a Pub/Sub event that each team's own system can use</a:t>
+              <a:t>Same evidence, one record: every inspection is a JSON record behind a REST API that each team's own system can use</a:t>
             </a:r>
             <a:endParaRPr sz="1350" b="0" i="0" u="none" strike="noStrike" cap="none">
               <a:solidFill>
@@ -44272,7 +44272,7 @@
                 <a:cs typeface="Google Sans Flex"/>
                 <a:sym typeface="Google Sans Flex"/>
               </a:rPr>
-              <a:t>HTML/PDF-ready report, Gemini Q&amp;A, a BigQuery row for portfolio analytics and a Pub/Sub event for underwriting and claims systems.</a:t>
+              <a:t>HTML/PDF-ready report, Gemini Q&amp;A and a JSON record over the REST API for underwriting and claims systems.</a:t>
             </a:r>
             <a:endParaRPr sz="1250" b="0" i="0" u="none" strike="noStrike" cap="none">
               <a:solidFill>
@@ -44461,7 +44461,7 @@
                 <a:cs typeface="Google Sans Flex"/>
                 <a:sym typeface="Google Sans Flex"/>
               </a:rPr>
-              <a:t>≈ $1</a:t>
+              <a:t>≈ $0.85</a:t>
             </a:r>
             <a:endParaRPr sz="2700" b="0" i="0" u="none" strike="noStrike" cap="none">
               <a:solidFill>
@@ -44524,7 +44524,7 @@
                 <a:cs typeface="Google Sans Flex"/>
                 <a:sym typeface="Google Sans Flex"/>
               </a:rPr>
-              <a:t>cloud cost per Lite video, GPU + Gemini</a:t>
+              <a:t>cloud cost per walkthrough, L4 Job + Gemini</a:t>
             </a:r>
             <a:endParaRPr sz="1150" b="0" i="0" u="none" strike="noStrike" cap="none">
               <a:solidFill>
@@ -44776,7 +44776,7 @@
                 <a:cs typeface="Google Sans Flex"/>
                 <a:sym typeface="Google Sans Flex"/>
               </a:rPr>
-              <a:t>GPU cost when idle: scales to zero</a:t>
+              <a:t>GPU cost when idle: the L4 Job runs only per video</a:t>
             </a:r>
             <a:endParaRPr sz="1150" b="0" i="0" u="none" strike="noStrike" cap="none">
               <a:solidFill>
@@ -44984,7 +44984,7 @@
                 <a:cs typeface="Google Sans Flex"/>
                 <a:sym typeface="Google Sans Flex"/>
               </a:rPr>
-              <a:t>One Cloud Run service, powered by Gemini on Vertex AI</a:t>
+              <a:t>Cloud Run web service + L4 GPU Job, powered by Gemini</a:t>
             </a:r>
             <a:endParaRPr sz="2850"/>
           </a:p>
@@ -45076,6 +45076,69 @@
           </a:prstGeom>
         </p:spPr>
       </p:pic>
+      <p:sp>
+        <p:nvSpPr>
+          <p:cNvPr id="9001" name="Architecture caption"/>
+          <p:cNvSpPr txBox="1"/>
+          <p:nvPr/>
+        </p:nvSpPr>
+        <p:spPr>
+          <a:xfrm>
+            <a:off x="548640" y="5961888"/>
+            <a:ext cx="11109960" cy="457200"/>
+          </a:xfrm>
+          <a:prstGeom prst="rect">
+            <a:avLst/>
+          </a:prstGeom>
+          <a:noFill/>
+          <a:ln>
+            <a:noFill/>
+          </a:ln>
+        </p:spPr>
+        <p:txBody>
+          <a:bodyPr spcFirstLastPara="1" wrap="square" lIns="0" tIns="0" rIns="0" bIns="0" anchor="t" anchorCtr="0">
+            <a:noAutofit/>
+          </a:bodyPr>
+          <a:lstStyle/>
+          <a:p>
+            <a:pPr marL="0" marR="0" lvl="0" indent="0" algn="l" rtl="0">
+              <a:spcBef>
+                <a:spcPts val="0"/>
+              </a:spcBef>
+              <a:spcAft>
+                <a:spcPts val="0"/>
+              </a:spcAft>
+              <a:buClr>
+                <a:schemeClr val="dk2"/>
+              </a:buClr>
+              <a:buSzPts val="1100"/>
+              <a:buFont typeface="Calibri"/>
+              <a:buNone/>
+            </a:pPr>
+            <a:r>
+              <a:rPr lang="en-US" sz="1000" b="0" i="1" u="none" strike="noStrike" cap="none">
+                <a:solidFill>
+                  <a:schemeClr val="dk2"/>
+                </a:solidFill>
+                <a:latin typeface="Google Sans Flex"/>
+                <a:ea typeface="Google Sans Flex"/>
+                <a:cs typeface="Google Sans Flex"/>
+                <a:sym typeface="Google Sans Flex"/>
+              </a:rPr>
+              <a:t>Deployed layout (v1.0.0): web UI + API on a CPU-only Cloud Run service; 3D engine, coverage and AI inspection on a Cloud Run Job with one NVIDIA L4 per video; a Cloud Storage bucket mounted on both for uploads, status and results; Gemini 3.8 Flash via the Gemini API (key in Secret Manager). BigQuery and Pub/Sub are not used.</a:t>
+            </a:r>
+            <a:endParaRPr sz="1000" b="0" i="0" u="none" strike="noStrike" cap="none">
+              <a:solidFill>
+                <a:schemeClr val="dk1"/>
+              </a:solidFill>
+              <a:latin typeface="Google Sans Flex"/>
+              <a:ea typeface="Google Sans Flex"/>
+              <a:cs typeface="Google Sans Flex"/>
+              <a:sym typeface="Google Sans Flex"/>
+            </a:endParaRPr>
+          </a:p>
+        </p:txBody>
+      </p:sp>
     </p:spTree>
   </p:cSld>
   <p:clrMapOvr>
@@ -45784,7 +45847,7 @@
                           <a:cs typeface="Google Sans Flex"/>
                           <a:sym typeface="Google Sans Flex"/>
                         </a:rPr>
-                        <a:t>Vertex AI</a:t>
+                        <a:t>Gemini API</a:t>
                       </a:r>
                       <a:endParaRPr sz="1150" u="none" strike="noStrike" cap="none">
                         <a:latin typeface="Google Sans Flex"/>
@@ -46115,7 +46178,7 @@
                           <a:cs typeface="Google Sans Flex"/>
                           <a:sym typeface="Google Sans Flex"/>
                         </a:rPr>
-                        <a:t>Cloud Run GPU</a:t>
+                        <a:t>Cloud Run GPU Job</a:t>
                       </a:r>
                       <a:endParaRPr sz="1150" u="none" strike="noStrike" cap="none">
                         <a:latin typeface="Google Sans Flex"/>
@@ -46446,7 +46509,7 @@
                           <a:cs typeface="Google Sans Flex"/>
                           <a:sym typeface="Google Sans Flex"/>
                         </a:rPr>
-                        <a:t>Cloud Run GPU</a:t>
+                        <a:t>Cloud Run GPU Job</a:t>
                       </a:r>
                       <a:endParaRPr sz="1150" u="none" strike="noStrike" cap="none">
                         <a:latin typeface="Google Sans Flex"/>
@@ -46777,7 +46840,7 @@
                           <a:cs typeface="Google Sans Flex"/>
                           <a:sym typeface="Google Sans Flex"/>
                         </a:rPr>
-                        <a:t>CPU + Vertex AI</a:t>
+                        <a:t>CPU + Gemini API</a:t>
                       </a:r>
                       <a:endParaRPr sz="1150" u="none" strike="noStrike" cap="none">
                         <a:latin typeface="Google Sans Flex"/>
@@ -47108,7 +47171,7 @@
                           <a:cs typeface="Google Sans Flex"/>
                           <a:sym typeface="Google Sans Flex"/>
                         </a:rPr>
-                        <a:t>CPU + Vertex AI</a:t>
+                        <a:t>CPU + Gemini API</a:t>
                       </a:r>
                       <a:endParaRPr sz="1150" u="none" strike="noStrike" cap="none">
                         <a:latin typeface="Google Sans Flex"/>
@@ -47439,7 +47502,7 @@
                           <a:cs typeface="Google Sans Flex"/>
                           <a:sym typeface="Google Sans Flex"/>
                         </a:rPr>
-                        <a:t>Cloud Run GPU</a:t>
+                        <a:t>Cloud Run GPU Job</a:t>
                       </a:r>
                       <a:endParaRPr sz="1150" u="none" strike="noStrike" cap="none">
                         <a:latin typeface="Google Sans Flex"/>
@@ -47770,7 +47833,7 @@
                           <a:cs typeface="Google Sans Flex"/>
                           <a:sym typeface="Google Sans Flex"/>
                         </a:rPr>
-                        <a:t>Vertex AI</a:t>
+                        <a:t>Gemini API</a:t>
                       </a:r>
                       <a:endParaRPr sz="1150" u="none" strike="noStrike" cap="none">
                         <a:latin typeface="Google Sans Flex"/>

</xml_diff>

<commit_message>
Redraw the architecture diagram for the deployed Cloud Run service + L4 Job layout
- New light and dark diagram: CPU-only Cloud Run service (upload, progress, report, Q&A, JSON API), a Cloud Run
  Job with one NVIDIA L4 per video (3D engine, coverage, AI inspection, risk engine), Gemini 3.8 Flash through the
  Gemini API with the key in Secret Manager, a Cloud Storage bucket mounted on both, Cloud Build and Artifact Registry
- Placed on the architecture slide of both decks with updated alt text; captions and other slides unchanged
- PDFs regenerated; docs/media diagram images updated
</commit_message>
<xml_diff>
--- a/docs/pitch-deck/Property_Inspection_AI_Pitch.pptx
+++ b/docs/pitch-deck/Property_Inspection_AI_Pitch.pptx
@@ -275,7 +275,7 @@
   </p:defaultTextStyle>
   <p:extLst>
     <p:ext uri="GoogleSlidesCustomDataVersion2">
-      <go:slidesCustomData xmlns:go="http://customooxmlschemas.google.com/" xmlns:ahyp="http://schemas.microsoft.com/office/drawing/2018/hyperlinkcolor" xmlns:p15="http://schemas.microsoft.com/office/powerpoint/2012/main" xmlns:p14="http://schemas.microsoft.com/office/powerpoint/2010/main" xmlns:com="http://schemas.openxmlformats.org/drawingml/2006/compatibility" xmlns:pvml="urn:schemas-microsoft-com:office:powerpoint" xmlns:v="urn:schemas-microsoft-com:vml" xmlns:o="urn:schemas-microsoft-com:office:office" xmlns:dgm="http://schemas.openxmlformats.org/drawingml/2006/diagram" xmlns:c="http://schemas.openxmlformats.org/drawingml/2006/chart" xmlns:mv="urn:schemas-microsoft-com:mac:vml" xmlns:mc="http://schemas.openxmlformats.org/markup-compatibility/2006" xmlns="" r:id="rId32" roundtripDataSignature="AMtx7mjOeDR1zCLjFyjkW6tyZyZfzfbbTQ=="/>
+      <go:slidesCustomData xmlns="" xmlns:mc="http://schemas.openxmlformats.org/markup-compatibility/2006" xmlns:mv="urn:schemas-microsoft-com:mac:vml" xmlns:c="http://schemas.openxmlformats.org/drawingml/2006/chart" xmlns:dgm="http://schemas.openxmlformats.org/drawingml/2006/diagram" xmlns:o="urn:schemas-microsoft-com:office:office" xmlns:v="urn:schemas-microsoft-com:vml" xmlns:pvml="urn:schemas-microsoft-com:office:powerpoint" xmlns:com="http://schemas.openxmlformats.org/drawingml/2006/compatibility" xmlns:p14="http://schemas.microsoft.com/office/powerpoint/2010/main" xmlns:p15="http://schemas.microsoft.com/office/powerpoint/2012/main" xmlns:ahyp="http://schemas.microsoft.com/office/drawing/2018/hyperlinkcolor" xmlns:go="http://customooxmlschemas.google.com/" r:id="rId32" roundtripDataSignature="AMtx7mjOeDR1zCLjFyjkW6tyZyZfzfbbTQ=="/>
     </p:ext>
   </p:extLst>
 </p:presentation>
@@ -45054,7 +45054,7 @@
       </p:sp>
       <p:pic>
         <p:nvPicPr>
-          <p:cNvPr id="282" name="Architecture diagram" descr="Architecture: users upload a phone walkthrough to one Cloud Run service with an L4 GPU. Inside it the web app, 3D engine, coverage, AI inspection, risk engine and 3D report run in sequence. It calls Gemini 3.8 Flash on Vertex AI and writes to Cloud Storage, BigQuery and Pub/Sub, which notifies core systems."/>
+          <p:cNvPr id="282" name="Architecture diagram" descr="Architecture: users upload a phone walkthrough to a CPU-only Cloud Run service, which starts a Cloud Run Job with one NVIDIA L4 GPU per video. The Job runs the 3D engine, coverage, AI inspection and risk engine; the service shows the 3D report, Ask Gemini and a JSON API. Gemini 3.8 Flash is called through the Gemini API with the key from Secret Manager, a Cloud Storage bucket is mounted on both, and Cloud Build and Artifact Registry build the one image both use."/>
           <p:cNvPicPr>
             <a:picLocks noChangeAspect="1"/>
           </p:cNvPicPr>

</xml_diff>

<commit_message>
Pitch deck roadmap: next an inspection agent (Gemini on Agent Platform: live capture guidance, spatial reasoning over the 3D model, answers per stakeholder), later agent hand-offs to core systems; PDF regenerated from the same file
</commit_message>
<xml_diff>
--- a/docs/pitch-deck/Property_Inspection_AI_Pitch.pptx
+++ b/docs/pitch-deck/Property_Inspection_AI_Pitch.pptx
@@ -275,7 +275,7 @@
   </p:defaultTextStyle>
   <p:extLst>
     <p:ext uri="GoogleSlidesCustomDataVersion2">
-      <go:slidesCustomData xmlns="" xmlns:mc="http://schemas.openxmlformats.org/markup-compatibility/2006" xmlns:mv="urn:schemas-microsoft-com:mac:vml" xmlns:c="http://schemas.openxmlformats.org/drawingml/2006/chart" xmlns:dgm="http://schemas.openxmlformats.org/drawingml/2006/diagram" xmlns:o="urn:schemas-microsoft-com:office:office" xmlns:v="urn:schemas-microsoft-com:vml" xmlns:pvml="urn:schemas-microsoft-com:office:powerpoint" xmlns:com="http://schemas.openxmlformats.org/drawingml/2006/compatibility" xmlns:p14="http://schemas.microsoft.com/office/powerpoint/2010/main" xmlns:p15="http://schemas.microsoft.com/office/powerpoint/2012/main" xmlns:ahyp="http://schemas.microsoft.com/office/drawing/2018/hyperlinkcolor" xmlns:go="http://customooxmlschemas.google.com/" r:id="rId32" roundtripDataSignature="AMtx7mjOeDR1zCLjFyjkW6tyZyZfzfbbTQ=="/>
+      <go:slidesCustomData xmlns:go="http://customooxmlschemas.google.com/" xmlns:ahyp="http://schemas.microsoft.com/office/drawing/2018/hyperlinkcolor" xmlns:p15="http://schemas.microsoft.com/office/powerpoint/2012/main" xmlns:p14="http://schemas.microsoft.com/office/powerpoint/2010/main" xmlns:com="http://schemas.openxmlformats.org/drawingml/2006/compatibility" xmlns:pvml="urn:schemas-microsoft-com:office:powerpoint" xmlns:v="urn:schemas-microsoft-com:vml" xmlns:o="urn:schemas-microsoft-com:office:office" xmlns:dgm="http://schemas.openxmlformats.org/drawingml/2006/diagram" xmlns:c="http://schemas.openxmlformats.org/drawingml/2006/chart" xmlns:mv="urn:schemas-microsoft-com:mac:vml" xmlns:mc="http://schemas.openxmlformats.org/markup-compatibility/2006" xmlns="" r:id="rId32" roundtripDataSignature="AMtx7mjOeDR1zCLjFyjkW6tyZyZfzfbbTQ=="/>
     </p:ext>
   </p:extLst>
 </p:presentation>
@@ -4438,7 +4438,7 @@
             </a:pPr>
             <a:r>
               <a:rPr lang="en-US"/>
-              <a:t>Roadmap: guided mobile capture, Document AI, Vertex AI Search and a commercial localiser next, then BigQuery ML risk scoring, before/after claim comparison and multilingual reports.</a:t>
+              <a:t>Roadmap: next, an inspection agent built with Gemini on Agent Platform (ADK) that guides capture live, reasons spatially over the 3D model and answers each stakeholder, with a person approving every decision. Later: agent hand-offs to loan and claims systems, Document AI and Vertex AI Search for deeds and policies, BigQuery ML risk scoring and before/after claim comparison in 3D.</a:t>
             </a:r>
             <a:endParaRPr/>
           </a:p>
@@ -35870,7 +35870,7 @@
                 <a:cs typeface="Google Sans Flex"/>
                 <a:sym typeface="Google Sans Flex"/>
               </a:rPr>
-              <a:t>Next: documents, policies and predictive portfolio risk</a:t>
+              <a:t>Next: an inspection agent, then portfolio-level risk</a:t>
             </a:r>
             <a:endParaRPr sz="2850"/>
           </a:p>
@@ -36358,7 +36358,7 @@
                 <a:cs typeface="Google Sans Flex"/>
                 <a:sym typeface="Google Sans Flex"/>
               </a:rPr>
-              <a:t>Mobile guided capture with live coverage feedback</a:t>
+              <a:t>Inspection agent built with Gemini on Agent Platform (ADK)</a:t>
             </a:r>
             <a:endParaRPr sz="1350" b="0" i="0" u="none" strike="noStrike" cap="none">
               <a:solidFill>
@@ -36395,7 +36395,7 @@
                 <a:cs typeface="Google Sans Flex"/>
                 <a:sym typeface="Google Sans Flex"/>
               </a:rPr>
-              <a:t>Document AI: deeds, valuation reports, invoices</a:t>
+              <a:t>Live capture guidance: tells the inspector what to film</a:t>
             </a:r>
             <a:endParaRPr sz="1350" b="0" i="0" u="none" strike="noStrike" cap="none">
               <a:solidFill>
@@ -36432,7 +36432,7 @@
                 <a:cs typeface="Google Sans Flex"/>
                 <a:sym typeface="Google Sans Flex"/>
               </a:rPr>
-              <a:t>Vertex AI Search over policy wording</a:t>
+              <a:t>Spatial reasoning over rooms, surfaces, objects, findings</a:t>
             </a:r>
             <a:endParaRPr sz="1350" b="0" i="0" u="none" strike="noStrike" cap="none">
               <a:solidFill>
@@ -36469,7 +36469,7 @@
                 <a:cs typeface="Google Sans Flex"/>
                 <a:sym typeface="Google Sans Flex"/>
               </a:rPr>
-              <a:t>Commercial localiser (Gemini / Vertex-tuned)</a:t>
+              <a:t>Answers for every stakeholder, with human approval</a:t>
             </a:r>
             <a:endParaRPr sz="1350" b="0" i="0" u="none" strike="noStrike" cap="none">
               <a:solidFill>
@@ -36717,7 +36717,7 @@
                 <a:cs typeface="Google Sans Flex"/>
                 <a:sym typeface="Google Sans Flex"/>
               </a:rPr>
-              <a:t>Multilingual reports (Gemini)</a:t>
+              <a:t>Document AI and Vertex AI Search: deeds and policies</a:t>
             </a:r>
             <a:endParaRPr sz="1350" b="0" i="0" u="none" strike="noStrike" cap="none">
               <a:solidFill>
@@ -36754,7 +36754,7 @@
                 <a:cs typeface="Google Sans Flex"/>
                 <a:sym typeface="Google Sans Flex"/>
               </a:rPr>
-              <a:t>AlloyDB multi-tenant case management</a:t>
+              <a:t>Agent hand-offs to loan and claims systems</a:t>
             </a:r>
             <a:endParaRPr sz="1350" b="0" i="0" u="none" strike="noStrike" cap="none">
               <a:solidFill>

</xml_diff>